<commit_message>
updates SDC pitch slide
</commit_message>
<xml_diff>
--- a/submission/DapurPlan_SDC2026_Pitch_Detailed.pptx
+++ b/submission/DapurPlan_SDC2026_Pitch_Detailed.pptx
@@ -376,7 +376,7 @@
             <a:pPr indent="0" algn="r">
               <a:buNone/>
             </a:pPr>
-            <a:fld id="{A4B7A4C2-DF99-4959-9C6E-6A807481FF8D}" type="slidenum">
+            <a:fld id="{22BBB48B-769F-4989-9D25-330F93910DD9}" type="slidenum">
               <a:rPr lang="en-US" sz="1400" b="0" u="none" strike="noStrike">
                 <a:solidFill>
                   <a:srgbClr val="000000"/>
@@ -577,7 +577,7 @@
               </a:lnSpc>
               <a:buNone/>
             </a:pPr>
-            <a:fld id="{75D2E544-5972-4CCE-AC27-C9A5C461868E}" type="slidenum">
+            <a:fld id="{DD520D45-2901-4CCD-81EA-6EDC3864CA65}" type="slidenum">
               <a:rPr lang="en-US" sz="1200" b="0" u="none" strike="noStrike">
                 <a:solidFill>
                   <a:srgbClr val="000000"/>
@@ -777,7 +777,7 @@
               </a:lnSpc>
               <a:buNone/>
             </a:pPr>
-            <a:fld id="{EF8EED6B-CB39-4D76-8923-DF11BA9966BC}" type="slidenum">
+            <a:fld id="{4980C1BD-E179-4552-92DE-0E53B4BA1CC8}" type="slidenum">
               <a:rPr lang="en-US" sz="1200" b="0" u="none" strike="noStrike">
                 <a:solidFill>
                   <a:srgbClr val="000000"/>
@@ -977,7 +977,7 @@
               </a:lnSpc>
               <a:buNone/>
             </a:pPr>
-            <a:fld id="{D47086DD-0297-4305-B135-0A516F59B68C}" type="slidenum">
+            <a:fld id="{F3CA2E05-DB59-4914-A9E3-9134EED92598}" type="slidenum">
               <a:rPr lang="en-US" sz="1200" b="0" u="none" strike="noStrike">
                 <a:solidFill>
                   <a:srgbClr val="000000"/>
@@ -1177,7 +1177,7 @@
               </a:lnSpc>
               <a:buNone/>
             </a:pPr>
-            <a:fld id="{FF595137-ACAD-4A2B-8086-B1180E081D70}" type="slidenum">
+            <a:fld id="{2F155390-0D8C-4C1F-9B5F-969D7AE62703}" type="slidenum">
               <a:rPr lang="en-US" sz="1200" b="0" u="none" strike="noStrike">
                 <a:solidFill>
                   <a:srgbClr val="000000"/>
@@ -1377,7 +1377,7 @@
               </a:lnSpc>
               <a:buNone/>
             </a:pPr>
-            <a:fld id="{E04D31A8-9B2E-42B0-B779-45C340DE27AE}" type="slidenum">
+            <a:fld id="{C838731C-0071-46BA-8F0B-0CA66663D868}" type="slidenum">
               <a:rPr lang="en-US" sz="1200" b="0" u="none" strike="noStrike">
                 <a:solidFill>
                   <a:srgbClr val="000000"/>
@@ -1577,7 +1577,7 @@
               </a:lnSpc>
               <a:buNone/>
             </a:pPr>
-            <a:fld id="{0D2B965F-3925-47B3-B61E-43F57CE9E53B}" type="slidenum">
+            <a:fld id="{2EC6BA32-61CA-4F41-A523-72F424F37E53}" type="slidenum">
               <a:rPr lang="en-US" sz="1200" b="0" u="none" strike="noStrike">
                 <a:solidFill>
                   <a:srgbClr val="000000"/>
@@ -1777,7 +1777,7 @@
               </a:lnSpc>
               <a:buNone/>
             </a:pPr>
-            <a:fld id="{2F9AD551-234C-442C-B8FE-D8C7AF570970}" type="slidenum">
+            <a:fld id="{2B861854-FE4E-421C-AC01-74168BC500AC}" type="slidenum">
               <a:rPr lang="en-US" sz="1200" b="0" u="none" strike="noStrike">
                 <a:solidFill>
                   <a:srgbClr val="000000"/>
@@ -1977,7 +1977,7 @@
               </a:lnSpc>
               <a:buNone/>
             </a:pPr>
-            <a:fld id="{3979B7FD-615C-47BF-A34F-9B03110E0511}" type="slidenum">
+            <a:fld id="{3AAF4D12-7BDE-4772-8912-2141E46D5E62}" type="slidenum">
               <a:rPr lang="en-US" sz="1200" b="0" u="none" strike="noStrike">
                 <a:solidFill>
                   <a:srgbClr val="000000"/>
@@ -2177,7 +2177,7 @@
               </a:lnSpc>
               <a:buNone/>
             </a:pPr>
-            <a:fld id="{1E3784CA-04C5-4400-A7FA-CE9867784AB7}" type="slidenum">
+            <a:fld id="{03CB79E4-592C-489E-AF96-282ECD1B741B}" type="slidenum">
               <a:rPr lang="en-US" sz="1200" b="0" u="none" strike="noStrike">
                 <a:solidFill>
                   <a:srgbClr val="000000"/>
@@ -2377,7 +2377,7 @@
               </a:lnSpc>
               <a:buNone/>
             </a:pPr>
-            <a:fld id="{64FC39B2-F0E3-4F8C-A6BE-B2D87EC7C47A}" type="slidenum">
+            <a:fld id="{D918A56E-A857-4648-A079-B0188987C32E}" type="slidenum">
               <a:rPr lang="en-US" sz="1200" b="0" u="none" strike="noStrike">
                 <a:solidFill>
                   <a:srgbClr val="000000"/>
@@ -2577,7 +2577,7 @@
               </a:lnSpc>
               <a:buNone/>
             </a:pPr>
-            <a:fld id="{A40E7C17-6512-4BE4-B765-25DC4F019CE8}" type="slidenum">
+            <a:fld id="{4509610E-DAB2-45DD-B25B-6465D6EB7EE7}" type="slidenum">
               <a:rPr lang="en-US" sz="1200" b="0" u="none" strike="noStrike">
                 <a:solidFill>
                   <a:srgbClr val="000000"/>
@@ -2777,7 +2777,7 @@
               </a:lnSpc>
               <a:buNone/>
             </a:pPr>
-            <a:fld id="{78A6D788-EEF3-4F92-98FA-EED54410B30C}" type="slidenum">
+            <a:fld id="{75F1A8B5-3557-4C2D-B8C4-CDE37585970E}" type="slidenum">
               <a:rPr lang="en-US" sz="1200" b="0" u="none" strike="noStrike">
                 <a:solidFill>
                   <a:srgbClr val="000000"/>
@@ -2887,18 +2887,7 @@
                 <a:uFillTx/>
                 <a:latin typeface="Calibri"/>
               </a:rPr>
-              <a:t>Click to edit </a:t>
-            </a:r>
-            <a:r>
-              <a:rPr lang="en-US" sz="4400" b="0" u="none" strike="noStrike">
-                <a:solidFill>
-                  <a:schemeClr val="dk1"/>
-                </a:solidFill>
-                <a:effectLst/>
-                <a:uFillTx/>
-                <a:latin typeface="Calibri"/>
-              </a:rPr>
-              <a:t>Master title style</a:t>
+              <a:t>Click to edit Master title style</a:t>
             </a:r>
             <a:endParaRPr lang="en-US" sz="4400" b="0" u="none" strike="noStrike">
               <a:solidFill>
@@ -3105,7 +3094,7 @@
               </a:lnSpc>
               <a:buNone/>
             </a:pPr>
-            <a:fld id="{ED4853F1-8CC5-4A45-BF7B-106604FE9C3A}" type="slidenum">
+            <a:fld id="{E7F6C60C-576B-4F9A-8850-8BC628BF332D}" type="slidenum">
               <a:rPr lang="en-US" sz="1200" b="0" u="none" strike="noStrike">
                 <a:solidFill>
                   <a:schemeClr val="dk1">
@@ -3814,7 +3803,7 @@
               </a:lnSpc>
               <a:buNone/>
             </a:pPr>
-            <a:fld id="{D1AA0046-BE94-40F7-9DC1-46EABE109038}" type="slidenum">
+            <a:fld id="{2D24C735-4627-42DF-BCC0-A3DBD81270F3}" type="slidenum">
               <a:rPr lang="en-US" sz="1200" b="0" u="none" strike="noStrike">
                 <a:solidFill>
                   <a:schemeClr val="dk1">
@@ -3926,7 +3915,40 @@
                 <a:uFillTx/>
                 <a:latin typeface="Calibri"/>
               </a:rPr>
-              <a:t>Click to edit Master title style</a:t>
+              <a:t>Click to </a:t>
+            </a:r>
+            <a:r>
+              <a:rPr lang="en-US" sz="2000" b="1" u="none" strike="noStrike">
+                <a:solidFill>
+                  <a:schemeClr val="dk1"/>
+                </a:solidFill>
+                <a:effectLst/>
+                <a:uFillTx/>
+                <a:latin typeface="Calibri"/>
+              </a:rPr>
+              <a:t>edit </a:t>
+            </a:r>
+            <a:r>
+              <a:rPr lang="en-US" sz="2000" b="1" u="none" strike="noStrike">
+                <a:solidFill>
+                  <a:schemeClr val="dk1"/>
+                </a:solidFill>
+                <a:effectLst/>
+                <a:uFillTx/>
+                <a:latin typeface="Calibri"/>
+              </a:rPr>
+              <a:t>Master </a:t>
+            </a:r>
+            <a:r>
+              <a:rPr lang="en-US" sz="2000" b="1" u="none" strike="noStrike">
+                <a:solidFill>
+                  <a:schemeClr val="dk1"/>
+                </a:solidFill>
+                <a:effectLst/>
+                <a:uFillTx/>
+                <a:latin typeface="Calibri"/>
+              </a:rPr>
+              <a:t>title style</a:t>
             </a:r>
             <a:endParaRPr lang="en-US" sz="2000" b="1" u="none" strike="noStrike">
               <a:solidFill>
@@ -4609,7 +4631,7 @@
               </a:lnSpc>
               <a:buNone/>
             </a:pPr>
-            <a:fld id="{C30CB645-15D0-4DC1-A562-B279D12C3D93}" type="slidenum">
+            <a:fld id="{8A576CF8-8312-4A5F-BAF6-765FA2804269}" type="slidenum">
               <a:rPr lang="en-US" sz="1200" b="0" u="none" strike="noStrike">
                 <a:solidFill>
                   <a:schemeClr val="dk1">
@@ -4721,29 +4743,7 @@
                 <a:uFillTx/>
                 <a:latin typeface="Calibri"/>
               </a:rPr>
-              <a:t>Click to edit </a:t>
-            </a:r>
-            <a:r>
-              <a:rPr lang="en-US" sz="4400" b="0" u="none" strike="noStrike">
-                <a:solidFill>
-                  <a:schemeClr val="dk1"/>
-                </a:solidFill>
-                <a:effectLst/>
-                <a:uFillTx/>
-                <a:latin typeface="Calibri"/>
-              </a:rPr>
-              <a:t>Master title </a:t>
-            </a:r>
-            <a:r>
-              <a:rPr lang="en-US" sz="4400" b="0" u="none" strike="noStrike">
-                <a:solidFill>
-                  <a:schemeClr val="dk1"/>
-                </a:solidFill>
-                <a:effectLst/>
-                <a:uFillTx/>
-                <a:latin typeface="Calibri"/>
-              </a:rPr>
-              <a:t>style</a:t>
+              <a:t>Click to edit Master title style</a:t>
             </a:r>
             <a:endParaRPr lang="en-US" sz="4400" b="0" u="none" strike="noStrike">
               <a:solidFill>
@@ -5256,7 +5256,7 @@
               </a:lnSpc>
               <a:buNone/>
             </a:pPr>
-            <a:fld id="{8B1F80F5-2820-4FC0-A99F-45A2239A122B}" type="slidenum">
+            <a:fld id="{9B79D9FC-71A4-488C-837A-FD086C762D4B}" type="slidenum">
               <a:rPr lang="en-US" sz="1200" b="0" u="none" strike="noStrike">
                 <a:solidFill>
                   <a:schemeClr val="dk1">
@@ -6222,7 +6222,7 @@
               </a:lnSpc>
               <a:buNone/>
             </a:pPr>
-            <a:fld id="{A30954B2-8252-40AD-8EB8-638A7D866159}" type="slidenum">
+            <a:fld id="{28E41470-7942-4880-89AF-B5602BD61686}" type="slidenum">
               <a:rPr lang="en-US" sz="1200" b="0" u="none" strike="noStrike">
                 <a:solidFill>
                   <a:schemeClr val="dk1">
@@ -6334,7 +6334,7 @@
                 <a:uFillTx/>
                 <a:latin typeface="Calibri"/>
               </a:rPr>
-              <a:t>Cl</a:t>
+              <a:t>Click to edit Master </a:t>
             </a:r>
             <a:r>
               <a:rPr lang="en-US" sz="4400" b="0" u="none" strike="noStrike">
@@ -6345,161 +6345,7 @@
                 <a:uFillTx/>
                 <a:latin typeface="Calibri"/>
               </a:rPr>
-              <a:t>ic</a:t>
-            </a:r>
-            <a:r>
-              <a:rPr lang="en-US" sz="4400" b="0" u="none" strike="noStrike">
-                <a:solidFill>
-                  <a:schemeClr val="dk1"/>
-                </a:solidFill>
-                <a:effectLst/>
-                <a:uFillTx/>
-                <a:latin typeface="Calibri"/>
-              </a:rPr>
-              <a:t>k </a:t>
-            </a:r>
-            <a:r>
-              <a:rPr lang="en-US" sz="4400" b="0" u="none" strike="noStrike">
-                <a:solidFill>
-                  <a:schemeClr val="dk1"/>
-                </a:solidFill>
-                <a:effectLst/>
-                <a:uFillTx/>
-                <a:latin typeface="Calibri"/>
-              </a:rPr>
-              <a:t>to </a:t>
-            </a:r>
-            <a:r>
-              <a:rPr lang="en-US" sz="4400" b="0" u="none" strike="noStrike">
-                <a:solidFill>
-                  <a:schemeClr val="dk1"/>
-                </a:solidFill>
-                <a:effectLst/>
-                <a:uFillTx/>
-                <a:latin typeface="Calibri"/>
-              </a:rPr>
-              <a:t>e</a:t>
-            </a:r>
-            <a:r>
-              <a:rPr lang="en-US" sz="4400" b="0" u="none" strike="noStrike">
-                <a:solidFill>
-                  <a:schemeClr val="dk1"/>
-                </a:solidFill>
-                <a:effectLst/>
-                <a:uFillTx/>
-                <a:latin typeface="Calibri"/>
-              </a:rPr>
-              <a:t>di</a:t>
-            </a:r>
-            <a:r>
-              <a:rPr lang="en-US" sz="4400" b="0" u="none" strike="noStrike">
-                <a:solidFill>
-                  <a:schemeClr val="dk1"/>
-                </a:solidFill>
-                <a:effectLst/>
-                <a:uFillTx/>
-                <a:latin typeface="Calibri"/>
-              </a:rPr>
-              <a:t>t </a:t>
-            </a:r>
-            <a:r>
-              <a:rPr lang="en-US" sz="4400" b="0" u="none" strike="noStrike">
-                <a:solidFill>
-                  <a:schemeClr val="dk1"/>
-                </a:solidFill>
-                <a:effectLst/>
-                <a:uFillTx/>
-                <a:latin typeface="Calibri"/>
-              </a:rPr>
-              <a:t>M</a:t>
-            </a:r>
-            <a:r>
-              <a:rPr lang="en-US" sz="4400" b="0" u="none" strike="noStrike">
-                <a:solidFill>
-                  <a:schemeClr val="dk1"/>
-                </a:solidFill>
-                <a:effectLst/>
-                <a:uFillTx/>
-                <a:latin typeface="Calibri"/>
-              </a:rPr>
-              <a:t>as</a:t>
-            </a:r>
-            <a:r>
-              <a:rPr lang="en-US" sz="4400" b="0" u="none" strike="noStrike">
-                <a:solidFill>
-                  <a:schemeClr val="dk1"/>
-                </a:solidFill>
-                <a:effectLst/>
-                <a:uFillTx/>
-                <a:latin typeface="Calibri"/>
-              </a:rPr>
-              <a:t>te</a:t>
-            </a:r>
-            <a:r>
-              <a:rPr lang="en-US" sz="4400" b="0" u="none" strike="noStrike">
-                <a:solidFill>
-                  <a:schemeClr val="dk1"/>
-                </a:solidFill>
-                <a:effectLst/>
-                <a:uFillTx/>
-                <a:latin typeface="Calibri"/>
-              </a:rPr>
-              <a:t>r </a:t>
-            </a:r>
-            <a:r>
-              <a:rPr lang="en-US" sz="4400" b="0" u="none" strike="noStrike">
-                <a:solidFill>
-                  <a:schemeClr val="dk1"/>
-                </a:solidFill>
-                <a:effectLst/>
-                <a:uFillTx/>
-                <a:latin typeface="Calibri"/>
-              </a:rPr>
-              <a:t>tit</a:t>
-            </a:r>
-            <a:r>
-              <a:rPr lang="en-US" sz="4400" b="0" u="none" strike="noStrike">
-                <a:solidFill>
-                  <a:schemeClr val="dk1"/>
-                </a:solidFill>
-                <a:effectLst/>
-                <a:uFillTx/>
-                <a:latin typeface="Calibri"/>
-              </a:rPr>
-              <a:t>le </a:t>
-            </a:r>
-            <a:r>
-              <a:rPr lang="en-US" sz="4400" b="0" u="none" strike="noStrike">
-                <a:solidFill>
-                  <a:schemeClr val="dk1"/>
-                </a:solidFill>
-                <a:effectLst/>
-                <a:uFillTx/>
-                <a:latin typeface="Calibri"/>
-              </a:rPr>
-              <a:t>st</a:t>
-            </a:r>
-            <a:r>
-              <a:rPr lang="en-US" sz="4400" b="0" u="none" strike="noStrike">
-                <a:solidFill>
-                  <a:schemeClr val="dk1"/>
-                </a:solidFill>
-                <a:effectLst/>
-                <a:uFillTx/>
-                <a:latin typeface="Calibri"/>
-              </a:rPr>
-              <a:t>yl</a:t>
-            </a:r>
-            <a:r>
-              <a:rPr lang="en-US" sz="4400" b="0" u="none" strike="noStrike">
-                <a:solidFill>
-                  <a:schemeClr val="dk1"/>
-                </a:solidFill>
-                <a:effectLst/>
-                <a:uFillTx/>
-                <a:latin typeface="Calibri"/>
-              </a:rPr>
-              <a:t>e</a:t>
+              <a:t>title style</a:t>
             </a:r>
             <a:endParaRPr lang="en-US" sz="4400" b="0" u="none" strike="noStrike">
               <a:solidFill>
@@ -7012,7 +6858,7 @@
               </a:lnSpc>
               <a:buNone/>
             </a:pPr>
-            <a:fld id="{9884AE2B-6AC7-45AD-A43B-C7359CDE5DDE}" type="slidenum">
+            <a:fld id="{81D27D93-6972-4AC9-9ABB-EC376C8B2C4C}" type="slidenum">
               <a:rPr lang="en-US" sz="1200" b="0" u="none" strike="noStrike">
                 <a:solidFill>
                   <a:schemeClr val="dk1">
@@ -7124,7 +6970,7 @@
                 <a:uFillTx/>
                 <a:latin typeface="Calibri"/>
               </a:rPr>
-              <a:t>Click </a:t>
+              <a:t>Click to edit </a:t>
             </a:r>
             <a:r>
               <a:rPr lang="en-US" sz="4000" b="1" u="none" strike="noStrike" cap="all">
@@ -7135,40 +6981,7 @@
                 <a:uFillTx/>
                 <a:latin typeface="Calibri"/>
               </a:rPr>
-              <a:t>to edit </a:t>
-            </a:r>
-            <a:r>
-              <a:rPr lang="en-US" sz="4000" b="1" u="none" strike="noStrike" cap="all">
-                <a:solidFill>
-                  <a:schemeClr val="dk1"/>
-                </a:solidFill>
-                <a:effectLst/>
-                <a:uFillTx/>
-                <a:latin typeface="Calibri"/>
-              </a:rPr>
-              <a:t>Maste</a:t>
-            </a:r>
-            <a:r>
-              <a:rPr lang="en-US" sz="4000" b="1" u="none" strike="noStrike" cap="all">
-                <a:solidFill>
-                  <a:schemeClr val="dk1"/>
-                </a:solidFill>
-                <a:effectLst/>
-                <a:uFillTx/>
-                <a:latin typeface="Calibri"/>
-              </a:rPr>
-              <a:t>r title </a:t>
-            </a:r>
-            <a:r>
-              <a:rPr lang="en-US" sz="4000" b="1" u="none" strike="noStrike" cap="all">
-                <a:solidFill>
-                  <a:schemeClr val="dk1"/>
-                </a:solidFill>
-                <a:effectLst/>
-                <a:uFillTx/>
-                <a:latin typeface="Calibri"/>
-              </a:rPr>
-              <a:t>style</a:t>
+              <a:t>Master title style</a:t>
             </a:r>
             <a:endParaRPr lang="en-US" sz="4000" b="1" u="none" strike="noStrike" cap="all">
               <a:solidFill>
@@ -7465,7 +7278,7 @@
               </a:lnSpc>
               <a:buNone/>
             </a:pPr>
-            <a:fld id="{979E1C95-C2AE-4569-8761-7840C0F46219}" type="slidenum">
+            <a:fld id="{3E3E2C37-FF0F-402F-8D6F-FEFBD438ADDE}" type="slidenum">
               <a:rPr lang="en-US" sz="1200" b="0" u="none" strike="noStrike">
                 <a:solidFill>
                   <a:schemeClr val="dk1">
@@ -7577,7 +7390,7 @@
                 <a:uFillTx/>
                 <a:latin typeface="Calibri"/>
               </a:rPr>
-              <a:t>Clic</a:t>
+              <a:t>Click </a:t>
             </a:r>
             <a:r>
               <a:rPr lang="en-US" sz="4400" b="0" u="none" strike="noStrike">
@@ -7588,7 +7401,7 @@
                 <a:uFillTx/>
                 <a:latin typeface="Calibri"/>
               </a:rPr>
-              <a:t>k </a:t>
+              <a:t>to edit </a:t>
             </a:r>
             <a:r>
               <a:rPr lang="en-US" sz="4400" b="0" u="none" strike="noStrike">
@@ -7599,7 +7412,7 @@
                 <a:uFillTx/>
                 <a:latin typeface="Calibri"/>
               </a:rPr>
-              <a:t>to </a:t>
+              <a:t>Maste</a:t>
             </a:r>
             <a:r>
               <a:rPr lang="en-US" sz="4400" b="0" u="none" strike="noStrike">
@@ -7610,7 +7423,7 @@
                 <a:uFillTx/>
                 <a:latin typeface="Calibri"/>
               </a:rPr>
-              <a:t>edi</a:t>
+              <a:t>r title </a:t>
             </a:r>
             <a:r>
               <a:rPr lang="en-US" sz="4400" b="0" u="none" strike="noStrike">
@@ -7621,84 +7434,7 @@
                 <a:uFillTx/>
                 <a:latin typeface="Calibri"/>
               </a:rPr>
-              <a:t>t </a:t>
-            </a:r>
-            <a:r>
-              <a:rPr lang="en-US" sz="4400" b="0" u="none" strike="noStrike">
-                <a:solidFill>
-                  <a:schemeClr val="dk1"/>
-                </a:solidFill>
-                <a:effectLst/>
-                <a:uFillTx/>
-                <a:latin typeface="Calibri"/>
-              </a:rPr>
-              <a:t>Ma</a:t>
-            </a:r>
-            <a:r>
-              <a:rPr lang="en-US" sz="4400" b="0" u="none" strike="noStrike">
-                <a:solidFill>
-                  <a:schemeClr val="dk1"/>
-                </a:solidFill>
-                <a:effectLst/>
-                <a:uFillTx/>
-                <a:latin typeface="Calibri"/>
-              </a:rPr>
-              <a:t>ste</a:t>
-            </a:r>
-            <a:r>
-              <a:rPr lang="en-US" sz="4400" b="0" u="none" strike="noStrike">
-                <a:solidFill>
-                  <a:schemeClr val="dk1"/>
-                </a:solidFill>
-                <a:effectLst/>
-                <a:uFillTx/>
-                <a:latin typeface="Calibri"/>
-              </a:rPr>
-              <a:t>r </a:t>
-            </a:r>
-            <a:r>
-              <a:rPr lang="en-US" sz="4400" b="0" u="none" strike="noStrike">
-                <a:solidFill>
-                  <a:schemeClr val="dk1"/>
-                </a:solidFill>
-                <a:effectLst/>
-                <a:uFillTx/>
-                <a:latin typeface="Calibri"/>
-              </a:rPr>
-              <a:t>titl</a:t>
-            </a:r>
-            <a:r>
-              <a:rPr lang="en-US" sz="4400" b="0" u="none" strike="noStrike">
-                <a:solidFill>
-                  <a:schemeClr val="dk1"/>
-                </a:solidFill>
-                <a:effectLst/>
-                <a:uFillTx/>
-                <a:latin typeface="Calibri"/>
-              </a:rPr>
-              <a:t>e </a:t>
-            </a:r>
-            <a:r>
-              <a:rPr lang="en-US" sz="4400" b="0" u="none" strike="noStrike">
-                <a:solidFill>
-                  <a:schemeClr val="dk1"/>
-                </a:solidFill>
-                <a:effectLst/>
-                <a:uFillTx/>
-                <a:latin typeface="Calibri"/>
-              </a:rPr>
-              <a:t>styl</a:t>
-            </a:r>
-            <a:r>
-              <a:rPr lang="en-US" sz="4400" b="0" u="none" strike="noStrike">
-                <a:solidFill>
-                  <a:schemeClr val="dk1"/>
-                </a:solidFill>
-                <a:effectLst/>
-                <a:uFillTx/>
-                <a:latin typeface="Calibri"/>
-              </a:rPr>
-              <a:t>e</a:t>
+              <a:t>style</a:t>
             </a:r>
             <a:endParaRPr lang="en-US" sz="4400" b="0" u="none" strike="noStrike">
               <a:solidFill>
@@ -8517,7 +8253,7 @@
               </a:lnSpc>
               <a:buNone/>
             </a:pPr>
-            <a:fld id="{9B379870-394E-40B1-9C74-3E507F5FB557}" type="slidenum">
+            <a:fld id="{C1816002-3155-439C-8D1A-E1F5AC2A9930}" type="slidenum">
               <a:rPr lang="en-US" sz="1200" b="0" u="none" strike="noStrike">
                 <a:solidFill>
                   <a:schemeClr val="dk1">
@@ -8629,73 +8365,7 @@
                 <a:uFillTx/>
                 <a:latin typeface="Calibri"/>
               </a:rPr>
-              <a:t>Click </a:t>
-            </a:r>
-            <a:r>
-              <a:rPr lang="en-US" sz="4400" b="0" u="none" strike="noStrike">
-                <a:solidFill>
-                  <a:schemeClr val="dk1"/>
-                </a:solidFill>
-                <a:effectLst/>
-                <a:uFillTx/>
-                <a:latin typeface="Calibri"/>
-              </a:rPr>
-              <a:t>to </a:t>
-            </a:r>
-            <a:r>
-              <a:rPr lang="en-US" sz="4400" b="0" u="none" strike="noStrike">
-                <a:solidFill>
-                  <a:schemeClr val="dk1"/>
-                </a:solidFill>
-                <a:effectLst/>
-                <a:uFillTx/>
-                <a:latin typeface="Calibri"/>
-              </a:rPr>
-              <a:t>edit </a:t>
-            </a:r>
-            <a:r>
-              <a:rPr lang="en-US" sz="4400" b="0" u="none" strike="noStrike">
-                <a:solidFill>
-                  <a:schemeClr val="dk1"/>
-                </a:solidFill>
-                <a:effectLst/>
-                <a:uFillTx/>
-                <a:latin typeface="Calibri"/>
-              </a:rPr>
-              <a:t>Mast</a:t>
-            </a:r>
-            <a:r>
-              <a:rPr lang="en-US" sz="4400" b="0" u="none" strike="noStrike">
-                <a:solidFill>
-                  <a:schemeClr val="dk1"/>
-                </a:solidFill>
-                <a:effectLst/>
-                <a:uFillTx/>
-                <a:latin typeface="Calibri"/>
-              </a:rPr>
-              <a:t>er </a:t>
-            </a:r>
-            <a:r>
-              <a:rPr lang="en-US" sz="4400" b="0" u="none" strike="noStrike">
-                <a:solidFill>
-                  <a:schemeClr val="dk1"/>
-                </a:solidFill>
-                <a:effectLst/>
-                <a:uFillTx/>
-                <a:latin typeface="Calibri"/>
-              </a:rPr>
-              <a:t>title </a:t>
-            </a:r>
-            <a:r>
-              <a:rPr lang="en-US" sz="4400" b="0" u="none" strike="noStrike">
-                <a:solidFill>
-                  <a:schemeClr val="dk1"/>
-                </a:solidFill>
-                <a:effectLst/>
-                <a:uFillTx/>
-                <a:latin typeface="Calibri"/>
-              </a:rPr>
-              <a:t>style</a:t>
+              <a:t>Click to edit Master title style</a:t>
             </a:r>
             <a:endParaRPr lang="en-US" sz="4400" b="0" u="none" strike="noStrike">
               <a:solidFill>
@@ -9742,7 +9412,7 @@
               </a:lnSpc>
               <a:buNone/>
             </a:pPr>
-            <a:fld id="{7451619F-DF38-4229-AD1A-C6A40D09A877}" type="slidenum">
+            <a:fld id="{3BF42922-886A-4893-86BA-E08EF25FD5C9}" type="slidenum">
               <a:rPr lang="en-US" sz="1200" b="0" u="none" strike="noStrike">
                 <a:solidFill>
                   <a:schemeClr val="dk1">
@@ -9854,18 +9524,7 @@
                 <a:uFillTx/>
                 <a:latin typeface="Calibri"/>
               </a:rPr>
-              <a:t>Click to edit </a:t>
-            </a:r>
-            <a:r>
-              <a:rPr lang="en-US" sz="4400" b="0" u="none" strike="noStrike">
-                <a:solidFill>
-                  <a:schemeClr val="dk1"/>
-                </a:solidFill>
-                <a:effectLst/>
-                <a:uFillTx/>
-                <a:latin typeface="Calibri"/>
-              </a:rPr>
-              <a:t>Master title style</a:t>
+              <a:t>Click to edit Master title style</a:t>
             </a:r>
             <a:endParaRPr lang="en-US" sz="4400" b="0" u="none" strike="noStrike">
               <a:solidFill>
@@ -10072,7 +9731,7 @@
               </a:lnSpc>
               <a:buNone/>
             </a:pPr>
-            <a:fld id="{C4B8D0BF-26F1-4511-97D4-0D0AE922D018}" type="slidenum">
+            <a:fld id="{779FB757-BAF7-46FF-9684-F0DE252FDAB1}" type="slidenum">
               <a:rPr lang="en-US" sz="1200" b="0" u="none" strike="noStrike">
                 <a:solidFill>
                   <a:schemeClr val="dk1">
@@ -10319,7 +9978,7 @@
               </a:lnSpc>
               <a:buNone/>
             </a:pPr>
-            <a:fld id="{BCDDA4B3-EC13-4E7D-B4CF-2C0D3275AD86}" type="slidenum">
+            <a:fld id="{D43D8A79-C2A5-4E4B-8DBA-072B18DC07AB}" type="slidenum">
               <a:rPr lang="en-US" sz="1200" b="0" u="none" strike="noStrike">
                 <a:solidFill>
                   <a:schemeClr val="dk1">
@@ -10396,7 +10055,18 @@
                 <a:uFillTx/>
                 <a:latin typeface="Calibri"/>
               </a:rPr>
-              <a:t>Click to edit the title text format</a:t>
+              <a:t>Click to edit the </a:t>
+            </a:r>
+            <a:r>
+              <a:rPr lang="en-US" sz="4400" b="0" u="none" strike="noStrike">
+                <a:solidFill>
+                  <a:schemeClr val="dk1"/>
+                </a:solidFill>
+                <a:effectLst/>
+                <a:uFillTx/>
+                <a:latin typeface="Calibri"/>
+              </a:rPr>
+              <a:t>title text format</a:t>
             </a:r>
             <a:endParaRPr lang="en-US" sz="4400" b="0" u="none" strike="noStrike">
               <a:solidFill>
@@ -11299,7 +10969,40 @@
                 <a:uFillTx/>
                 <a:latin typeface="Noto Sans"/>
               </a:rPr>
-              <a:t>DapurPlan</a:t>
+              <a:t>Da</a:t>
+            </a:r>
+            <a:r>
+              <a:rPr lang="en-US" sz="2300" b="1" u="none" strike="noStrike">
+                <a:solidFill>
+                  <a:srgbClr val="FFFFFF"/>
+                </a:solidFill>
+                <a:effectLst/>
+                <a:uFillTx/>
+                <a:latin typeface="Noto Sans"/>
+              </a:rPr>
+              <a:t>pur</a:t>
+            </a:r>
+            <a:r>
+              <a:rPr lang="en-US" sz="2300" b="1" u="none" strike="noStrike">
+                <a:solidFill>
+                  <a:srgbClr val="FFFFFF"/>
+                </a:solidFill>
+                <a:effectLst/>
+                <a:uFillTx/>
+                <a:latin typeface="Noto Sans"/>
+              </a:rPr>
+              <a:t>Pla</a:t>
+            </a:r>
+            <a:r>
+              <a:rPr lang="en-US" sz="2300" b="1" u="none" strike="noStrike">
+                <a:solidFill>
+                  <a:srgbClr val="FFFFFF"/>
+                </a:solidFill>
+                <a:effectLst/>
+                <a:uFillTx/>
+                <a:latin typeface="Noto Sans"/>
+              </a:rPr>
+              <a:t>n</a:t>
             </a:r>
             <a:endParaRPr lang="en-US" sz="2300" b="0" u="none" strike="noStrike">
               <a:solidFill>
@@ -12456,8 +12159,8 @@
         </p:nvSpPr>
         <p:spPr>
           <a:xfrm>
-            <a:off x="4974480" y="5367600"/>
-            <a:ext cx="5760360" cy="420120"/>
+            <a:off x="5029200" y="5365080"/>
+            <a:ext cx="5715000" cy="205200"/>
           </a:xfrm>
           <a:prstGeom prst="rect">
             <a:avLst/>
@@ -26405,7 +26108,18 @@
                 <a:uFillTx/>
                 <a:latin typeface="Noto Sans"/>
               </a:rPr>
-              <a:t>YESTERDAY</a:t>
+              <a:t>YESTERD</a:t>
+            </a:r>
+            <a:r>
+              <a:rPr lang="en-US" sz="700" b="1" u="none" strike="noStrike">
+                <a:solidFill>
+                  <a:srgbClr val="2563EB"/>
+                </a:solidFill>
+                <a:effectLst/>
+                <a:uFillTx/>
+                <a:latin typeface="Noto Sans"/>
+              </a:rPr>
+              <a:t>AY</a:t>
             </a:r>
             <a:endParaRPr lang="en-US" sz="700" b="0" u="none" strike="noStrike">
               <a:solidFill>

</xml_diff>